<commit_message>
Done with Stage 1
</commit_message>
<xml_diff>
--- a/RISC-V stage 1.pptx
+++ b/RISC-V stage 1.pptx
@@ -259,7 +259,7 @@
           <a:p>
             <a:fld id="{51AFF834-1BEC-4F95-9622-28B5DCC1FE16}" type="datetimeFigureOut">
               <a:rPr lang="en-US" smtClean="0"/>
-              <a:t>7/1/2025</a:t>
+              <a:t>3/8/2026</a:t>
             </a:fld>
             <a:endParaRPr lang="en-US"/>
           </a:p>
@@ -457,7 +457,7 @@
           <a:p>
             <a:fld id="{51AFF834-1BEC-4F95-9622-28B5DCC1FE16}" type="datetimeFigureOut">
               <a:rPr lang="en-US" smtClean="0"/>
-              <a:t>7/1/2025</a:t>
+              <a:t>3/8/2026</a:t>
             </a:fld>
             <a:endParaRPr lang="en-US"/>
           </a:p>
@@ -665,7 +665,7 @@
           <a:p>
             <a:fld id="{51AFF834-1BEC-4F95-9622-28B5DCC1FE16}" type="datetimeFigureOut">
               <a:rPr lang="en-US" smtClean="0"/>
-              <a:t>7/1/2025</a:t>
+              <a:t>3/8/2026</a:t>
             </a:fld>
             <a:endParaRPr lang="en-US"/>
           </a:p>
@@ -863,7 +863,7 @@
           <a:p>
             <a:fld id="{51AFF834-1BEC-4F95-9622-28B5DCC1FE16}" type="datetimeFigureOut">
               <a:rPr lang="en-US" smtClean="0"/>
-              <a:t>7/1/2025</a:t>
+              <a:t>3/8/2026</a:t>
             </a:fld>
             <a:endParaRPr lang="en-US"/>
           </a:p>
@@ -1138,7 +1138,7 @@
           <a:p>
             <a:fld id="{51AFF834-1BEC-4F95-9622-28B5DCC1FE16}" type="datetimeFigureOut">
               <a:rPr lang="en-US" smtClean="0"/>
-              <a:t>7/1/2025</a:t>
+              <a:t>3/8/2026</a:t>
             </a:fld>
             <a:endParaRPr lang="en-US"/>
           </a:p>
@@ -1403,7 +1403,7 @@
           <a:p>
             <a:fld id="{51AFF834-1BEC-4F95-9622-28B5DCC1FE16}" type="datetimeFigureOut">
               <a:rPr lang="en-US" smtClean="0"/>
-              <a:t>7/1/2025</a:t>
+              <a:t>3/8/2026</a:t>
             </a:fld>
             <a:endParaRPr lang="en-US"/>
           </a:p>
@@ -1815,7 +1815,7 @@
           <a:p>
             <a:fld id="{51AFF834-1BEC-4F95-9622-28B5DCC1FE16}" type="datetimeFigureOut">
               <a:rPr lang="en-US" smtClean="0"/>
-              <a:t>7/1/2025</a:t>
+              <a:t>3/8/2026</a:t>
             </a:fld>
             <a:endParaRPr lang="en-US"/>
           </a:p>
@@ -1956,7 +1956,7 @@
           <a:p>
             <a:fld id="{51AFF834-1BEC-4F95-9622-28B5DCC1FE16}" type="datetimeFigureOut">
               <a:rPr lang="en-US" smtClean="0"/>
-              <a:t>7/1/2025</a:t>
+              <a:t>3/8/2026</a:t>
             </a:fld>
             <a:endParaRPr lang="en-US"/>
           </a:p>
@@ -2069,7 +2069,7 @@
           <a:p>
             <a:fld id="{51AFF834-1BEC-4F95-9622-28B5DCC1FE16}" type="datetimeFigureOut">
               <a:rPr lang="en-US" smtClean="0"/>
-              <a:t>7/1/2025</a:t>
+              <a:t>3/8/2026</a:t>
             </a:fld>
             <a:endParaRPr lang="en-US"/>
           </a:p>
@@ -2380,7 +2380,7 @@
           <a:p>
             <a:fld id="{51AFF834-1BEC-4F95-9622-28B5DCC1FE16}" type="datetimeFigureOut">
               <a:rPr lang="en-US" smtClean="0"/>
-              <a:t>7/1/2025</a:t>
+              <a:t>3/8/2026</a:t>
             </a:fld>
             <a:endParaRPr lang="en-US"/>
           </a:p>
@@ -2668,7 +2668,7 @@
           <a:p>
             <a:fld id="{51AFF834-1BEC-4F95-9622-28B5DCC1FE16}" type="datetimeFigureOut">
               <a:rPr lang="en-US" smtClean="0"/>
-              <a:t>7/1/2025</a:t>
+              <a:t>3/8/2026</a:t>
             </a:fld>
             <a:endParaRPr lang="en-US"/>
           </a:p>
@@ -2909,7 +2909,7 @@
           <a:p>
             <a:fld id="{51AFF834-1BEC-4F95-9622-28B5DCC1FE16}" type="datetimeFigureOut">
               <a:rPr lang="en-US" smtClean="0"/>
-              <a:t>7/1/2025</a:t>
+              <a:t>3/8/2026</a:t>
             </a:fld>
             <a:endParaRPr lang="en-US"/>
           </a:p>
@@ -3746,7 +3746,7 @@
         </p:nvSpPr>
         <p:spPr>
           <a:xfrm>
-            <a:off x="389615" y="2231217"/>
+            <a:off x="156248" y="2169306"/>
             <a:ext cx="302982" cy="864909"/>
           </a:xfrm>
           <a:prstGeom prst="rect">
@@ -3798,7 +3798,7 @@
         </p:nvSpPr>
         <p:spPr>
           <a:xfrm>
-            <a:off x="367821" y="2540560"/>
+            <a:off x="143871" y="2445713"/>
             <a:ext cx="346570" cy="246221"/>
           </a:xfrm>
           <a:prstGeom prst="rect">
@@ -4571,10 +4571,10 @@
       </p:cxnSp>
       <p:cxnSp>
         <p:nvCxnSpPr>
-          <p:cNvPr id="56" name="Straight Arrow Connector 55">
-            <a:extLst>
-              <a:ext uri="{FF2B5EF4-FFF2-40B4-BE49-F238E27FC236}">
-                <a16:creationId xmlns:a16="http://schemas.microsoft.com/office/drawing/2014/main" id="{C49D7864-D93C-BF99-66FF-D2C4F2C00D63}"/>
+          <p:cNvPr id="60" name="Straight Connector 59">
+            <a:extLst>
+              <a:ext uri="{FF2B5EF4-FFF2-40B4-BE49-F238E27FC236}">
+                <a16:creationId xmlns:a16="http://schemas.microsoft.com/office/drawing/2014/main" id="{8242732E-8C7A-B59A-A71F-EE6E1C3473D7}"/>
               </a:ext>
             </a:extLst>
           </p:cNvPr>
@@ -4585,47 +4585,8 @@
         </p:nvCxnSpPr>
         <p:spPr>
           <a:xfrm>
-            <a:off x="692597" y="2702044"/>
-            <a:ext cx="298844" cy="0"/>
-          </a:xfrm>
-          <a:prstGeom prst="straightConnector1">
-            <a:avLst/>
-          </a:prstGeom>
-          <a:ln>
-            <a:tailEnd type="triangle"/>
-          </a:ln>
-        </p:spPr>
-        <p:style>
-          <a:lnRef idx="2">
-            <a:schemeClr val="accent1"/>
-          </a:lnRef>
-          <a:fillRef idx="0">
-            <a:schemeClr val="accent1"/>
-          </a:fillRef>
-          <a:effectRef idx="1">
-            <a:schemeClr val="accent1"/>
-          </a:effectRef>
-          <a:fontRef idx="minor">
-            <a:schemeClr val="tx1"/>
-          </a:fontRef>
-        </p:style>
-      </p:cxnSp>
-      <p:cxnSp>
-        <p:nvCxnSpPr>
-          <p:cNvPr id="60" name="Straight Connector 59">
-            <a:extLst>
-              <a:ext uri="{FF2B5EF4-FFF2-40B4-BE49-F238E27FC236}">
-                <a16:creationId xmlns:a16="http://schemas.microsoft.com/office/drawing/2014/main" id="{8242732E-8C7A-B59A-A71F-EE6E1C3473D7}"/>
-              </a:ext>
-            </a:extLst>
-          </p:cNvPr>
-          <p:cNvCxnSpPr/>
-          <p:nvPr/>
-        </p:nvCxnSpPr>
-        <p:spPr>
-          <a:xfrm>
             <a:off x="791700" y="1699822"/>
-            <a:ext cx="0" cy="1002222"/>
+            <a:ext cx="0" cy="745891"/>
           </a:xfrm>
           <a:prstGeom prst="line">
             <a:avLst/>
@@ -4691,13 +4652,15 @@
               </a:ext>
             </a:extLst>
           </p:cNvPr>
-          <p:cNvCxnSpPr/>
+          <p:cNvCxnSpPr>
+            <a:cxnSpLocks/>
+          </p:cNvCxnSpPr>
           <p:nvPr/>
         </p:nvCxnSpPr>
         <p:spPr>
           <a:xfrm>
-            <a:off x="211807" y="2702044"/>
-            <a:ext cx="177808" cy="0"/>
+            <a:off x="40920" y="2717971"/>
+            <a:ext cx="127351" cy="3809"/>
           </a:xfrm>
           <a:prstGeom prst="straightConnector1">
             <a:avLst/>
@@ -5918,16 +5881,20 @@
               </a:ext>
             </a:extLst>
           </p:cNvPr>
-          <p:cNvCxnSpPr/>
+          <p:cNvCxnSpPr>
+            <a:cxnSpLocks/>
+          </p:cNvCxnSpPr>
           <p:nvPr/>
         </p:nvCxnSpPr>
         <p:spPr>
-          <a:xfrm>
-            <a:off x="3216369" y="3387564"/>
-            <a:ext cx="177808" cy="0"/>
-          </a:xfrm>
-          <a:prstGeom prst="straightConnector1">
-            <a:avLst/>
+          <a:xfrm flipV="1">
+            <a:off x="2973787" y="3400264"/>
+            <a:ext cx="420390" cy="407183"/>
+          </a:xfrm>
+          <a:prstGeom prst="bentConnector3">
+            <a:avLst>
+              <a:gd name="adj1" fmla="val -48183"/>
+            </a:avLst>
           </a:prstGeom>
           <a:ln>
             <a:solidFill>
@@ -8239,8 +8206,8 @@
         </p:nvSpPr>
         <p:spPr>
           <a:xfrm>
-            <a:off x="8659919" y="1793810"/>
-            <a:ext cx="413896" cy="230832"/>
+            <a:off x="8445266" y="1701425"/>
+            <a:ext cx="625492" cy="230832"/>
           </a:xfrm>
           <a:prstGeom prst="rect">
             <a:avLst/>
@@ -8256,7 +8223,7 @@
             <a:pPr algn="ctr"/>
             <a:r>
               <a:rPr lang="en-US" sz="900" dirty="0" err="1"/>
-              <a:t>dout</a:t>
+              <a:t>data_out</a:t>
             </a:r>
             <a:endParaRPr lang="en-US" sz="900" dirty="0"/>
           </a:p>
@@ -8278,7 +8245,7 @@
         </p:nvCxnSpPr>
         <p:spPr>
           <a:xfrm>
-            <a:off x="4886953" y="1941884"/>
+            <a:off x="4877429" y="1922832"/>
             <a:ext cx="3239733" cy="0"/>
           </a:xfrm>
           <a:prstGeom prst="straightConnector1">
@@ -8317,8 +8284,8 @@
         </p:nvSpPr>
         <p:spPr>
           <a:xfrm>
-            <a:off x="8081009" y="2060991"/>
-            <a:ext cx="591829" cy="230832"/>
+            <a:off x="8054399" y="2041766"/>
+            <a:ext cx="412293" cy="230832"/>
           </a:xfrm>
           <a:prstGeom prst="rect">
             <a:avLst/>
@@ -8333,9 +8300,10 @@
           <a:p>
             <a:pPr algn="ctr"/>
             <a:r>
-              <a:rPr lang="en-US" sz="900" dirty="0"/>
-              <a:t>Address</a:t>
-            </a:r>
+              <a:rPr lang="en-US" sz="900" dirty="0" err="1"/>
+              <a:t>addr</a:t>
+            </a:r>
+            <a:endParaRPr lang="en-US" sz="900" dirty="0"/>
           </a:p>
         </p:txBody>
       </p:sp>
@@ -8431,13 +8399,15 @@
               </a:ext>
             </a:extLst>
           </p:cNvPr>
-          <p:cNvCxnSpPr/>
+          <p:cNvCxnSpPr>
+            <a:cxnSpLocks/>
+          </p:cNvCxnSpPr>
           <p:nvPr/>
         </p:nvCxnSpPr>
         <p:spPr>
           <a:xfrm flipV="1">
             <a:off x="8716191" y="2434882"/>
-            <a:ext cx="0" cy="167673"/>
+            <a:ext cx="0" cy="351899"/>
           </a:xfrm>
           <a:prstGeom prst="straightConnector1">
             <a:avLst/>
@@ -8760,8 +8730,8 @@
         </p:nvSpPr>
         <p:spPr>
           <a:xfrm>
-            <a:off x="8230139" y="2245179"/>
-            <a:ext cx="287259" cy="230832"/>
+            <a:off x="8073953" y="2245179"/>
+            <a:ext cx="718466" cy="230832"/>
           </a:xfrm>
           <a:prstGeom prst="rect">
             <a:avLst/>
@@ -8777,7 +8747,7 @@
             <a:pPr algn="ctr"/>
             <a:r>
               <a:rPr lang="en-US" sz="900" dirty="0" err="1"/>
-              <a:t>rd</a:t>
+              <a:t>mem_read</a:t>
             </a:r>
             <a:endParaRPr lang="en-US" sz="900" dirty="0"/>
           </a:p>
@@ -8797,8 +8767,8 @@
         </p:nvSpPr>
         <p:spPr>
           <a:xfrm>
-            <a:off x="8565545" y="2241709"/>
-            <a:ext cx="306495" cy="230832"/>
+            <a:off x="8302384" y="2119818"/>
+            <a:ext cx="740908" cy="230832"/>
           </a:xfrm>
           <a:prstGeom prst="rect">
             <a:avLst/>
@@ -8814,7 +8784,7 @@
             <a:pPr algn="ctr"/>
             <a:r>
               <a:rPr lang="en-US" sz="900" dirty="0" err="1"/>
-              <a:t>wr</a:t>
+              <a:t>mem_write</a:t>
             </a:r>
             <a:endParaRPr lang="en-US" sz="900" dirty="0"/>
           </a:p>
@@ -9220,13 +9190,15 @@
               </a:ext>
             </a:extLst>
           </p:cNvPr>
-          <p:cNvCxnSpPr/>
+          <p:cNvCxnSpPr>
+            <a:cxnSpLocks/>
+          </p:cNvCxnSpPr>
           <p:nvPr/>
         </p:nvCxnSpPr>
         <p:spPr>
           <a:xfrm flipH="1">
-            <a:off x="211807" y="6023113"/>
-            <a:ext cx="9458967" cy="0"/>
+            <a:off x="40920" y="6023113"/>
+            <a:ext cx="9629854" cy="0"/>
           </a:xfrm>
           <a:prstGeom prst="line">
             <a:avLst/>
@@ -9261,7 +9233,7 @@
         </p:nvCxnSpPr>
         <p:spPr>
           <a:xfrm flipV="1">
-            <a:off x="211807" y="2717971"/>
+            <a:off x="49882" y="2726139"/>
             <a:ext cx="0" cy="3295203"/>
           </a:xfrm>
           <a:prstGeom prst="line">
@@ -9861,7 +9833,7 @@
         <p:spPr>
           <a:xfrm flipV="1">
             <a:off x="10852467" y="3154000"/>
-            <a:ext cx="0" cy="195214"/>
+            <a:ext cx="0" cy="1365030"/>
           </a:xfrm>
           <a:prstGeom prst="straightConnector1">
             <a:avLst/>
@@ -9942,8 +9914,8 @@
         </p:nvCxnSpPr>
         <p:spPr>
           <a:xfrm flipV="1">
-            <a:off x="9202288" y="1919827"/>
-            <a:ext cx="0" cy="824398"/>
+            <a:off x="9202288" y="1796717"/>
+            <a:ext cx="0" cy="947508"/>
           </a:xfrm>
           <a:prstGeom prst="line">
             <a:avLst/>
@@ -9980,7 +9952,7 @@
         </p:nvCxnSpPr>
         <p:spPr>
           <a:xfrm flipH="1">
-            <a:off x="9014468" y="1909226"/>
+            <a:off x="9014468" y="1807626"/>
             <a:ext cx="195255" cy="0"/>
           </a:xfrm>
           <a:prstGeom prst="line">
@@ -10256,6 +10228,1105 @@
               <a:rPr lang="en-US" sz="1000" dirty="0"/>
               <a:t>ALU</a:t>
             </a:r>
+          </a:p>
+        </p:txBody>
+      </p:sp>
+      <p:sp>
+        <p:nvSpPr>
+          <p:cNvPr id="3" name="TextBox 2">
+            <a:extLst>
+              <a:ext uri="{FF2B5EF4-FFF2-40B4-BE49-F238E27FC236}">
+                <a16:creationId xmlns:a16="http://schemas.microsoft.com/office/drawing/2014/main" id="{5DFE6113-73D8-4C40-BD33-3B76433D1E1D}"/>
+              </a:ext>
+            </a:extLst>
+          </p:cNvPr>
+          <p:cNvSpPr txBox="1"/>
+          <p:nvPr/>
+        </p:nvSpPr>
+        <p:spPr>
+          <a:xfrm>
+            <a:off x="10646510" y="4516095"/>
+            <a:ext cx="436338" cy="230832"/>
+          </a:xfrm>
+          <a:prstGeom prst="rect">
+            <a:avLst/>
+          </a:prstGeom>
+          <a:noFill/>
+        </p:spPr>
+        <p:txBody>
+          <a:bodyPr wrap="none" rtlCol="0">
+            <a:spAutoFit/>
+          </a:bodyPr>
+          <a:lstStyle/>
+          <a:p>
+            <a:pPr algn="ctr"/>
+            <a:r>
+              <a:rPr lang="en-US" sz="900" dirty="0"/>
+              <a:t>state</a:t>
+            </a:r>
+          </a:p>
+        </p:txBody>
+      </p:sp>
+      <p:sp>
+        <p:nvSpPr>
+          <p:cNvPr id="10" name="TextBox 9">
+            <a:extLst>
+              <a:ext uri="{FF2B5EF4-FFF2-40B4-BE49-F238E27FC236}">
+                <a16:creationId xmlns:a16="http://schemas.microsoft.com/office/drawing/2014/main" id="{14B1648E-DA3D-2E94-D56B-428A76B38B6F}"/>
+              </a:ext>
+            </a:extLst>
+          </p:cNvPr>
+          <p:cNvSpPr txBox="1"/>
+          <p:nvPr/>
+        </p:nvSpPr>
+        <p:spPr>
+          <a:xfrm>
+            <a:off x="10251850" y="4681190"/>
+            <a:ext cx="1323237" cy="507831"/>
+          </a:xfrm>
+          <a:prstGeom prst="rect">
+            <a:avLst/>
+          </a:prstGeom>
+          <a:noFill/>
+        </p:spPr>
+        <p:txBody>
+          <a:bodyPr wrap="square" rtlCol="0">
+            <a:spAutoFit/>
+          </a:bodyPr>
+          <a:lstStyle/>
+          <a:p>
+            <a:pPr algn="ctr"/>
+            <a:r>
+              <a:rPr lang="en-US" sz="900" dirty="0" err="1"/>
+              <a:t>load_addr</a:t>
+            </a:r>
+            <a:endParaRPr lang="en-US" sz="900" dirty="0"/>
+          </a:p>
+          <a:p>
+            <a:pPr algn="ctr"/>
+            <a:r>
+              <a:rPr lang="en-US" sz="900" dirty="0" err="1"/>
+              <a:t>mem_read</a:t>
+            </a:r>
+            <a:endParaRPr lang="en-US" sz="900" dirty="0"/>
+          </a:p>
+          <a:p>
+            <a:pPr algn="ctr"/>
+            <a:r>
+              <a:rPr lang="en-US" sz="900" dirty="0" err="1"/>
+              <a:t>reg_write</a:t>
+            </a:r>
+            <a:endParaRPr lang="en-US" sz="900" dirty="0"/>
+          </a:p>
+        </p:txBody>
+      </p:sp>
+      <p:sp>
+        <p:nvSpPr>
+          <p:cNvPr id="17" name="TextBox 16">
+            <a:extLst>
+              <a:ext uri="{FF2B5EF4-FFF2-40B4-BE49-F238E27FC236}">
+                <a16:creationId xmlns:a16="http://schemas.microsoft.com/office/drawing/2014/main" id="{E42CD325-BB94-7C10-87C0-6236AC69A734}"/>
+              </a:ext>
+            </a:extLst>
+          </p:cNvPr>
+          <p:cNvSpPr txBox="1"/>
+          <p:nvPr/>
+        </p:nvSpPr>
+        <p:spPr>
+          <a:xfrm>
+            <a:off x="11073075" y="2725346"/>
+            <a:ext cx="607859" cy="230832"/>
+          </a:xfrm>
+          <a:prstGeom prst="rect">
+            <a:avLst/>
+          </a:prstGeom>
+          <a:noFill/>
+        </p:spPr>
+        <p:txBody>
+          <a:bodyPr wrap="none" rtlCol="0">
+            <a:spAutoFit/>
+          </a:bodyPr>
+          <a:lstStyle/>
+          <a:p>
+            <a:pPr algn="ctr"/>
+            <a:r>
+              <a:rPr lang="en-US" sz="900" dirty="0" err="1"/>
+              <a:t>wb_data</a:t>
+            </a:r>
+            <a:endParaRPr lang="en-US" sz="900" dirty="0"/>
+          </a:p>
+        </p:txBody>
+      </p:sp>
+      <p:sp>
+        <p:nvSpPr>
+          <p:cNvPr id="18" name="TextBox 17">
+            <a:extLst>
+              <a:ext uri="{FF2B5EF4-FFF2-40B4-BE49-F238E27FC236}">
+                <a16:creationId xmlns:a16="http://schemas.microsoft.com/office/drawing/2014/main" id="{0F403B61-DA33-78B7-9D4E-AFFAE09846A7}"/>
+              </a:ext>
+            </a:extLst>
+          </p:cNvPr>
+          <p:cNvSpPr txBox="1"/>
+          <p:nvPr/>
+        </p:nvSpPr>
+        <p:spPr>
+          <a:xfrm>
+            <a:off x="2514763" y="3018022"/>
+            <a:ext cx="607859" cy="230832"/>
+          </a:xfrm>
+          <a:prstGeom prst="rect">
+            <a:avLst/>
+          </a:prstGeom>
+          <a:noFill/>
+        </p:spPr>
+        <p:txBody>
+          <a:bodyPr wrap="none" rtlCol="0">
+            <a:spAutoFit/>
+          </a:bodyPr>
+          <a:lstStyle/>
+          <a:p>
+            <a:pPr algn="ctr"/>
+            <a:r>
+              <a:rPr lang="en-US" sz="900" dirty="0" err="1"/>
+              <a:t>wb_data</a:t>
+            </a:r>
+            <a:endParaRPr lang="en-US" sz="900" dirty="0"/>
+          </a:p>
+        </p:txBody>
+      </p:sp>
+      <p:sp>
+        <p:nvSpPr>
+          <p:cNvPr id="21" name="TextBox 20">
+            <a:extLst>
+              <a:ext uri="{FF2B5EF4-FFF2-40B4-BE49-F238E27FC236}">
+                <a16:creationId xmlns:a16="http://schemas.microsoft.com/office/drawing/2014/main" id="{6AA69742-815C-D190-8069-60B0F864357E}"/>
+              </a:ext>
+            </a:extLst>
+          </p:cNvPr>
+          <p:cNvSpPr txBox="1"/>
+          <p:nvPr/>
+        </p:nvSpPr>
+        <p:spPr>
+          <a:xfrm>
+            <a:off x="2900728" y="3667477"/>
+            <a:ext cx="1003832" cy="230832"/>
+          </a:xfrm>
+          <a:prstGeom prst="rect">
+            <a:avLst/>
+          </a:prstGeom>
+          <a:noFill/>
+        </p:spPr>
+        <p:txBody>
+          <a:bodyPr wrap="square" rtlCol="0">
+            <a:spAutoFit/>
+          </a:bodyPr>
+          <a:lstStyle/>
+          <a:p>
+            <a:pPr algn="ctr"/>
+            <a:r>
+              <a:rPr lang="en-US" sz="900" dirty="0" err="1"/>
+              <a:t>reg_write_chip</a:t>
+            </a:r>
+            <a:endParaRPr lang="en-US" sz="900" dirty="0"/>
+          </a:p>
+        </p:txBody>
+      </p:sp>
+      <p:sp>
+        <p:nvSpPr>
+          <p:cNvPr id="37" name="TextBox 36">
+            <a:extLst>
+              <a:ext uri="{FF2B5EF4-FFF2-40B4-BE49-F238E27FC236}">
+                <a16:creationId xmlns:a16="http://schemas.microsoft.com/office/drawing/2014/main" id="{F393CF6A-FC21-0D28-95F8-D66D0BDAFFF8}"/>
+              </a:ext>
+            </a:extLst>
+          </p:cNvPr>
+          <p:cNvSpPr txBox="1"/>
+          <p:nvPr/>
+        </p:nvSpPr>
+        <p:spPr>
+          <a:xfrm>
+            <a:off x="6349987" y="1979138"/>
+            <a:ext cx="1661032" cy="230832"/>
+          </a:xfrm>
+          <a:prstGeom prst="rect">
+            <a:avLst/>
+          </a:prstGeom>
+          <a:noFill/>
+        </p:spPr>
+        <p:txBody>
+          <a:bodyPr wrap="none" rtlCol="0">
+            <a:spAutoFit/>
+          </a:bodyPr>
+          <a:lstStyle/>
+          <a:p>
+            <a:r>
+              <a:rPr lang="en-US" sz="900" dirty="0" err="1"/>
+              <a:t>data_memory_byte_not_word</a:t>
+            </a:r>
+            <a:endParaRPr lang="en-US" sz="900" dirty="0"/>
+          </a:p>
+        </p:txBody>
+      </p:sp>
+      <p:sp>
+        <p:nvSpPr>
+          <p:cNvPr id="38" name="Rectangle 37">
+            <a:extLst>
+              <a:ext uri="{FF2B5EF4-FFF2-40B4-BE49-F238E27FC236}">
+                <a16:creationId xmlns:a16="http://schemas.microsoft.com/office/drawing/2014/main" id="{E96AF305-10A8-3491-5943-5F0A14D29FB3}"/>
+              </a:ext>
+            </a:extLst>
+          </p:cNvPr>
+          <p:cNvSpPr/>
+          <p:nvPr/>
+        </p:nvSpPr>
+        <p:spPr>
+          <a:xfrm>
+            <a:off x="6483597" y="2283932"/>
+            <a:ext cx="458402" cy="318623"/>
+          </a:xfrm>
+          <a:prstGeom prst="rect">
+            <a:avLst/>
+          </a:prstGeom>
+          <a:solidFill>
+            <a:schemeClr val="bg1"/>
+          </a:solidFill>
+        </p:spPr>
+        <p:style>
+          <a:lnRef idx="2">
+            <a:schemeClr val="accent1">
+              <a:shade val="15000"/>
+            </a:schemeClr>
+          </a:lnRef>
+          <a:fillRef idx="1">
+            <a:schemeClr val="accent1"/>
+          </a:fillRef>
+          <a:effectRef idx="0">
+            <a:schemeClr val="accent1"/>
+          </a:effectRef>
+          <a:fontRef idx="minor">
+            <a:schemeClr val="lt1"/>
+          </a:fontRef>
+        </p:style>
+        <p:txBody>
+          <a:bodyPr rtlCol="0" anchor="ctr"/>
+          <a:lstStyle/>
+          <a:p>
+            <a:pPr algn="ctr"/>
+            <a:r>
+              <a:rPr lang="en-US" dirty="0">
+                <a:solidFill>
+                  <a:schemeClr val="tx1"/>
+                </a:solidFill>
+              </a:rPr>
+              <a:t>÷4</a:t>
+            </a:r>
+          </a:p>
+        </p:txBody>
+      </p:sp>
+      <p:sp>
+        <p:nvSpPr>
+          <p:cNvPr id="39" name="TextBox 38">
+            <a:extLst>
+              <a:ext uri="{FF2B5EF4-FFF2-40B4-BE49-F238E27FC236}">
+                <a16:creationId xmlns:a16="http://schemas.microsoft.com/office/drawing/2014/main" id="{25F11691-03AF-1655-65B4-57B9DE162975}"/>
+              </a:ext>
+            </a:extLst>
+          </p:cNvPr>
+          <p:cNvSpPr txBox="1"/>
+          <p:nvPr/>
+        </p:nvSpPr>
+        <p:spPr>
+          <a:xfrm>
+            <a:off x="6653890" y="2760349"/>
+            <a:ext cx="679994" cy="230832"/>
+          </a:xfrm>
+          <a:prstGeom prst="rect">
+            <a:avLst/>
+          </a:prstGeom>
+          <a:noFill/>
+        </p:spPr>
+        <p:txBody>
+          <a:bodyPr wrap="none" rtlCol="0">
+            <a:spAutoFit/>
+          </a:bodyPr>
+          <a:lstStyle/>
+          <a:p>
+            <a:r>
+              <a:rPr lang="en-US" sz="900" dirty="0" err="1"/>
+              <a:t>alu_result</a:t>
+            </a:r>
+            <a:endParaRPr lang="en-US" sz="900" dirty="0"/>
+          </a:p>
+        </p:txBody>
+      </p:sp>
+      <p:sp>
+        <p:nvSpPr>
+          <p:cNvPr id="47" name="TextBox 46">
+            <a:extLst>
+              <a:ext uri="{FF2B5EF4-FFF2-40B4-BE49-F238E27FC236}">
+                <a16:creationId xmlns:a16="http://schemas.microsoft.com/office/drawing/2014/main" id="{E28644BD-CDE6-705D-BFBD-4A6EE1FBB85B}"/>
+              </a:ext>
+            </a:extLst>
+          </p:cNvPr>
+          <p:cNvSpPr txBox="1"/>
+          <p:nvPr/>
+        </p:nvSpPr>
+        <p:spPr>
+          <a:xfrm>
+            <a:off x="9246609" y="2534041"/>
+            <a:ext cx="716863" cy="230832"/>
+          </a:xfrm>
+          <a:prstGeom prst="rect">
+            <a:avLst/>
+          </a:prstGeom>
+          <a:noFill/>
+        </p:spPr>
+        <p:txBody>
+          <a:bodyPr wrap="none" rtlCol="0">
+            <a:spAutoFit/>
+          </a:bodyPr>
+          <a:lstStyle/>
+          <a:p>
+            <a:r>
+              <a:rPr lang="en-US" sz="900" dirty="0" err="1"/>
+              <a:t>mem_data</a:t>
+            </a:r>
+            <a:endParaRPr lang="en-US" sz="900" dirty="0"/>
+          </a:p>
+        </p:txBody>
+      </p:sp>
+      <p:sp>
+        <p:nvSpPr>
+          <p:cNvPr id="52" name="TextBox 51">
+            <a:extLst>
+              <a:ext uri="{FF2B5EF4-FFF2-40B4-BE49-F238E27FC236}">
+                <a16:creationId xmlns:a16="http://schemas.microsoft.com/office/drawing/2014/main" id="{2970CB1E-7868-6C1E-7ECE-61477D36594A}"/>
+              </a:ext>
+            </a:extLst>
+          </p:cNvPr>
+          <p:cNvSpPr txBox="1"/>
+          <p:nvPr/>
+        </p:nvSpPr>
+        <p:spPr>
+          <a:xfrm>
+            <a:off x="7985049" y="2543665"/>
+            <a:ext cx="718466" cy="230832"/>
+          </a:xfrm>
+          <a:prstGeom prst="rect">
+            <a:avLst/>
+          </a:prstGeom>
+          <a:noFill/>
+        </p:spPr>
+        <p:txBody>
+          <a:bodyPr wrap="none" rtlCol="0">
+            <a:spAutoFit/>
+          </a:bodyPr>
+          <a:lstStyle/>
+          <a:p>
+            <a:pPr algn="ctr"/>
+            <a:r>
+              <a:rPr lang="en-US" sz="900" dirty="0" err="1"/>
+              <a:t>mem_read</a:t>
+            </a:r>
+            <a:endParaRPr lang="en-US" sz="900" dirty="0"/>
+          </a:p>
+        </p:txBody>
+      </p:sp>
+      <p:sp>
+        <p:nvSpPr>
+          <p:cNvPr id="53" name="TextBox 52">
+            <a:extLst>
+              <a:ext uri="{FF2B5EF4-FFF2-40B4-BE49-F238E27FC236}">
+                <a16:creationId xmlns:a16="http://schemas.microsoft.com/office/drawing/2014/main" id="{8E02633D-E917-2EF8-39F3-0C51CB635BA2}"/>
+              </a:ext>
+            </a:extLst>
+          </p:cNvPr>
+          <p:cNvSpPr txBox="1"/>
+          <p:nvPr/>
+        </p:nvSpPr>
+        <p:spPr>
+          <a:xfrm>
+            <a:off x="8249321" y="2719414"/>
+            <a:ext cx="1010213" cy="230832"/>
+          </a:xfrm>
+          <a:prstGeom prst="rect">
+            <a:avLst/>
+          </a:prstGeom>
+          <a:noFill/>
+        </p:spPr>
+        <p:txBody>
+          <a:bodyPr wrap="none" rtlCol="0">
+            <a:spAutoFit/>
+          </a:bodyPr>
+          <a:lstStyle/>
+          <a:p>
+            <a:pPr algn="ctr"/>
+            <a:r>
+              <a:rPr lang="en-US" sz="900" dirty="0" err="1"/>
+              <a:t>mem_write_chip</a:t>
+            </a:r>
+            <a:endParaRPr lang="en-US" sz="900" dirty="0"/>
+          </a:p>
+        </p:txBody>
+      </p:sp>
+      <p:sp>
+        <p:nvSpPr>
+          <p:cNvPr id="57" name="TextBox 56">
+            <a:extLst>
+              <a:ext uri="{FF2B5EF4-FFF2-40B4-BE49-F238E27FC236}">
+                <a16:creationId xmlns:a16="http://schemas.microsoft.com/office/drawing/2014/main" id="{EA23A3C6-DC46-60DE-AA79-7BC7345365C5}"/>
+              </a:ext>
+            </a:extLst>
+          </p:cNvPr>
+          <p:cNvSpPr txBox="1"/>
+          <p:nvPr/>
+        </p:nvSpPr>
+        <p:spPr>
+          <a:xfrm>
+            <a:off x="2950024" y="4381214"/>
+            <a:ext cx="2085358" cy="369332"/>
+          </a:xfrm>
+          <a:prstGeom prst="rect">
+            <a:avLst/>
+          </a:prstGeom>
+          <a:noFill/>
+        </p:spPr>
+        <p:txBody>
+          <a:bodyPr wrap="square" rtlCol="0">
+            <a:spAutoFit/>
+          </a:bodyPr>
+          <a:lstStyle/>
+          <a:p>
+            <a:pPr algn="ctr"/>
+            <a:r>
+              <a:rPr lang="en-US" sz="900" dirty="0" err="1"/>
+              <a:t>Reg_write</a:t>
+            </a:r>
+            <a:r>
+              <a:rPr lang="en-US" sz="900" dirty="0"/>
+              <a:t>, </a:t>
+            </a:r>
+            <a:r>
+              <a:rPr lang="en-US" sz="900" dirty="0" err="1"/>
+              <a:t>mem_read</a:t>
+            </a:r>
+            <a:r>
+              <a:rPr lang="en-US" sz="900" dirty="0"/>
+              <a:t>, </a:t>
+            </a:r>
+            <a:r>
+              <a:rPr lang="en-US" sz="900" dirty="0" err="1"/>
+              <a:t>mem_write</a:t>
+            </a:r>
+            <a:r>
+              <a:rPr lang="en-US" sz="900" dirty="0"/>
+              <a:t>, </a:t>
+            </a:r>
+            <a:r>
+              <a:rPr lang="en-US" sz="900" dirty="0" err="1"/>
+              <a:t>alu_src</a:t>
+            </a:r>
+            <a:r>
+              <a:rPr lang="en-US" sz="900" dirty="0"/>
+              <a:t>, branch, </a:t>
+            </a:r>
+            <a:r>
+              <a:rPr lang="en-US" sz="900" dirty="0" err="1"/>
+              <a:t>load_addr</a:t>
+            </a:r>
+            <a:r>
+              <a:rPr lang="en-US" sz="900" dirty="0"/>
+              <a:t>, jump</a:t>
+            </a:r>
+          </a:p>
+        </p:txBody>
+      </p:sp>
+      <p:sp>
+        <p:nvSpPr>
+          <p:cNvPr id="58" name="TextBox 57">
+            <a:extLst>
+              <a:ext uri="{FF2B5EF4-FFF2-40B4-BE49-F238E27FC236}">
+                <a16:creationId xmlns:a16="http://schemas.microsoft.com/office/drawing/2014/main" id="{42869E4C-2B1D-095C-DE60-CE11B4C5595E}"/>
+              </a:ext>
+            </a:extLst>
+          </p:cNvPr>
+          <p:cNvSpPr txBox="1"/>
+          <p:nvPr/>
+        </p:nvSpPr>
+        <p:spPr>
+          <a:xfrm>
+            <a:off x="3216795" y="5268523"/>
+            <a:ext cx="521297" cy="230832"/>
+          </a:xfrm>
+          <a:prstGeom prst="rect">
+            <a:avLst/>
+          </a:prstGeom>
+          <a:noFill/>
+        </p:spPr>
+        <p:txBody>
+          <a:bodyPr wrap="none" rtlCol="0">
+            <a:spAutoFit/>
+          </a:bodyPr>
+          <a:lstStyle/>
+          <a:p>
+            <a:pPr algn="ctr"/>
+            <a:r>
+              <a:rPr lang="en-US" sz="900" dirty="0" err="1"/>
+              <a:t>alu_op</a:t>
+            </a:r>
+            <a:endParaRPr lang="en-US" sz="900" dirty="0"/>
+          </a:p>
+        </p:txBody>
+      </p:sp>
+      <p:sp>
+        <p:nvSpPr>
+          <p:cNvPr id="61" name="Rectangle 60">
+            <a:extLst>
+              <a:ext uri="{FF2B5EF4-FFF2-40B4-BE49-F238E27FC236}">
+                <a16:creationId xmlns:a16="http://schemas.microsoft.com/office/drawing/2014/main" id="{793EB3DC-733B-081D-0C47-0BEE4B8C28EE}"/>
+              </a:ext>
+            </a:extLst>
+          </p:cNvPr>
+          <p:cNvSpPr/>
+          <p:nvPr/>
+        </p:nvSpPr>
+        <p:spPr>
+          <a:xfrm>
+            <a:off x="578272" y="2819609"/>
+            <a:ext cx="293862" cy="194736"/>
+          </a:xfrm>
+          <a:prstGeom prst="rect">
+            <a:avLst/>
+          </a:prstGeom>
+          <a:solidFill>
+            <a:schemeClr val="bg1"/>
+          </a:solidFill>
+        </p:spPr>
+        <p:style>
+          <a:lnRef idx="2">
+            <a:schemeClr val="accent1">
+              <a:shade val="15000"/>
+            </a:schemeClr>
+          </a:lnRef>
+          <a:fillRef idx="1">
+            <a:schemeClr val="accent1"/>
+          </a:fillRef>
+          <a:effectRef idx="0">
+            <a:schemeClr val="accent1"/>
+          </a:effectRef>
+          <a:fontRef idx="minor">
+            <a:schemeClr val="lt1"/>
+          </a:fontRef>
+        </p:style>
+        <p:txBody>
+          <a:bodyPr rtlCol="0" anchor="ctr"/>
+          <a:lstStyle/>
+          <a:p>
+            <a:pPr algn="ctr"/>
+            <a:r>
+              <a:rPr lang="en-US" sz="800" dirty="0">
+                <a:solidFill>
+                  <a:schemeClr val="tx1"/>
+                </a:solidFill>
+              </a:rPr>
+              <a:t>÷4</a:t>
+            </a:r>
+          </a:p>
+        </p:txBody>
+      </p:sp>
+      <p:cxnSp>
+        <p:nvCxnSpPr>
+          <p:cNvPr id="82" name="Straight Arrow Connector 81">
+            <a:extLst>
+              <a:ext uri="{FF2B5EF4-FFF2-40B4-BE49-F238E27FC236}">
+                <a16:creationId xmlns:a16="http://schemas.microsoft.com/office/drawing/2014/main" id="{3894F305-A2CB-134D-8BE7-7C7AC106B25E}"/>
+              </a:ext>
+            </a:extLst>
+          </p:cNvPr>
+          <p:cNvCxnSpPr>
+            <a:cxnSpLocks/>
+          </p:cNvCxnSpPr>
+          <p:nvPr/>
+        </p:nvCxnSpPr>
+        <p:spPr>
+          <a:xfrm>
+            <a:off x="878973" y="2914541"/>
+            <a:ext cx="119042" cy="0"/>
+          </a:xfrm>
+          <a:prstGeom prst="straightConnector1">
+            <a:avLst/>
+          </a:prstGeom>
+          <a:ln>
+            <a:tailEnd type="triangle"/>
+          </a:ln>
+        </p:spPr>
+        <p:style>
+          <a:lnRef idx="2">
+            <a:schemeClr val="accent1"/>
+          </a:lnRef>
+          <a:fillRef idx="0">
+            <a:schemeClr val="accent1"/>
+          </a:fillRef>
+          <a:effectRef idx="1">
+            <a:schemeClr val="accent1"/>
+          </a:effectRef>
+          <a:fontRef idx="minor">
+            <a:schemeClr val="tx1"/>
+          </a:fontRef>
+        </p:style>
+      </p:cxnSp>
+      <p:cxnSp>
+        <p:nvCxnSpPr>
+          <p:cNvPr id="86" name="Straight Connector 85">
+            <a:extLst>
+              <a:ext uri="{FF2B5EF4-FFF2-40B4-BE49-F238E27FC236}">
+                <a16:creationId xmlns:a16="http://schemas.microsoft.com/office/drawing/2014/main" id="{21682F43-549C-7FE8-7DCC-6A8DC1E39769}"/>
+              </a:ext>
+            </a:extLst>
+          </p:cNvPr>
+          <p:cNvCxnSpPr>
+            <a:cxnSpLocks/>
+          </p:cNvCxnSpPr>
+          <p:nvPr/>
+        </p:nvCxnSpPr>
+        <p:spPr>
+          <a:xfrm flipH="1">
+            <a:off x="459230" y="2434882"/>
+            <a:ext cx="331969" cy="0"/>
+          </a:xfrm>
+          <a:prstGeom prst="line">
+            <a:avLst/>
+          </a:prstGeom>
+        </p:spPr>
+        <p:style>
+          <a:lnRef idx="2">
+            <a:schemeClr val="accent1"/>
+          </a:lnRef>
+          <a:fillRef idx="0">
+            <a:schemeClr val="accent1"/>
+          </a:fillRef>
+          <a:effectRef idx="1">
+            <a:schemeClr val="accent1"/>
+          </a:effectRef>
+          <a:fontRef idx="minor">
+            <a:schemeClr val="tx1"/>
+          </a:fontRef>
+        </p:style>
+      </p:cxnSp>
+      <p:cxnSp>
+        <p:nvCxnSpPr>
+          <p:cNvPr id="92" name="Straight Arrow Connector 91">
+            <a:extLst>
+              <a:ext uri="{FF2B5EF4-FFF2-40B4-BE49-F238E27FC236}">
+                <a16:creationId xmlns:a16="http://schemas.microsoft.com/office/drawing/2014/main" id="{5A0AF230-3963-1F87-2162-1EA502563A8C}"/>
+              </a:ext>
+            </a:extLst>
+          </p:cNvPr>
+          <p:cNvCxnSpPr>
+            <a:cxnSpLocks/>
+            <a:endCxn id="61" idx="0"/>
+          </p:cNvCxnSpPr>
+          <p:nvPr/>
+        </p:nvCxnSpPr>
+        <p:spPr>
+          <a:xfrm>
+            <a:off x="725203" y="2434882"/>
+            <a:ext cx="0" cy="384727"/>
+          </a:xfrm>
+          <a:prstGeom prst="straightConnector1">
+            <a:avLst/>
+          </a:prstGeom>
+          <a:ln>
+            <a:tailEnd type="triangle"/>
+          </a:ln>
+        </p:spPr>
+        <p:style>
+          <a:lnRef idx="2">
+            <a:schemeClr val="accent1"/>
+          </a:lnRef>
+          <a:fillRef idx="0">
+            <a:schemeClr val="accent1"/>
+          </a:fillRef>
+          <a:effectRef idx="1">
+            <a:schemeClr val="accent1"/>
+          </a:effectRef>
+          <a:fontRef idx="minor">
+            <a:schemeClr val="tx1"/>
+          </a:fontRef>
+        </p:style>
+      </p:cxnSp>
+      <p:sp>
+        <p:nvSpPr>
+          <p:cNvPr id="109" name="TextBox 108">
+            <a:extLst>
+              <a:ext uri="{FF2B5EF4-FFF2-40B4-BE49-F238E27FC236}">
+                <a16:creationId xmlns:a16="http://schemas.microsoft.com/office/drawing/2014/main" id="{E20EC053-880B-A909-EA31-B6D063EAE1F4}"/>
+              </a:ext>
+            </a:extLst>
+          </p:cNvPr>
+          <p:cNvSpPr txBox="1"/>
+          <p:nvPr/>
+        </p:nvSpPr>
+        <p:spPr>
+          <a:xfrm>
+            <a:off x="2246897" y="2357587"/>
+            <a:ext cx="1130438" cy="200055"/>
+          </a:xfrm>
+          <a:prstGeom prst="rect">
+            <a:avLst/>
+          </a:prstGeom>
+          <a:noFill/>
+        </p:spPr>
+        <p:txBody>
+          <a:bodyPr wrap="none" rtlCol="0">
+            <a:spAutoFit/>
+          </a:bodyPr>
+          <a:lstStyle/>
+          <a:p>
+            <a:pPr algn="ctr"/>
+            <a:r>
+              <a:rPr lang="en-US" sz="700" dirty="0" err="1"/>
+              <a:t>if_id_instr</a:t>
+            </a:r>
+            <a:r>
+              <a:rPr lang="en-US" sz="700" dirty="0"/>
+              <a:t>(19 </a:t>
+            </a:r>
+            <a:r>
+              <a:rPr lang="en-US" sz="700" dirty="0" err="1"/>
+              <a:t>downto</a:t>
+            </a:r>
+            <a:r>
+              <a:rPr lang="en-US" sz="700" dirty="0"/>
+              <a:t> 15)</a:t>
+            </a:r>
+          </a:p>
+        </p:txBody>
+      </p:sp>
+      <p:sp>
+        <p:nvSpPr>
+          <p:cNvPr id="110" name="TextBox 109">
+            <a:extLst>
+              <a:ext uri="{FF2B5EF4-FFF2-40B4-BE49-F238E27FC236}">
+                <a16:creationId xmlns:a16="http://schemas.microsoft.com/office/drawing/2014/main" id="{EB15CF0D-B2C7-E6B1-4FA6-CB9697F5A4CE}"/>
+              </a:ext>
+            </a:extLst>
+          </p:cNvPr>
+          <p:cNvSpPr txBox="1"/>
+          <p:nvPr/>
+        </p:nvSpPr>
+        <p:spPr>
+          <a:xfrm>
+            <a:off x="2256728" y="2587626"/>
+            <a:ext cx="1130438" cy="200055"/>
+          </a:xfrm>
+          <a:prstGeom prst="rect">
+            <a:avLst/>
+          </a:prstGeom>
+          <a:noFill/>
+        </p:spPr>
+        <p:txBody>
+          <a:bodyPr wrap="none" rtlCol="0">
+            <a:spAutoFit/>
+          </a:bodyPr>
+          <a:lstStyle/>
+          <a:p>
+            <a:pPr algn="ctr"/>
+            <a:r>
+              <a:rPr lang="en-US" sz="700" dirty="0" err="1"/>
+              <a:t>if_id_instr</a:t>
+            </a:r>
+            <a:r>
+              <a:rPr lang="en-US" sz="700" dirty="0"/>
+              <a:t>(24 </a:t>
+            </a:r>
+            <a:r>
+              <a:rPr lang="en-US" sz="700" dirty="0" err="1"/>
+              <a:t>downto</a:t>
+            </a:r>
+            <a:r>
+              <a:rPr lang="en-US" sz="700" dirty="0"/>
+              <a:t> 20)</a:t>
+            </a:r>
+          </a:p>
+        </p:txBody>
+      </p:sp>
+      <p:sp>
+        <p:nvSpPr>
+          <p:cNvPr id="118" name="TextBox 117">
+            <a:extLst>
+              <a:ext uri="{FF2B5EF4-FFF2-40B4-BE49-F238E27FC236}">
+                <a16:creationId xmlns:a16="http://schemas.microsoft.com/office/drawing/2014/main" id="{E8D46C79-63F7-2039-5CBE-20DA18F157E5}"/>
+              </a:ext>
+            </a:extLst>
+          </p:cNvPr>
+          <p:cNvSpPr txBox="1"/>
+          <p:nvPr/>
+        </p:nvSpPr>
+        <p:spPr>
+          <a:xfrm>
+            <a:off x="2289518" y="2804940"/>
+            <a:ext cx="1082348" cy="200055"/>
+          </a:xfrm>
+          <a:prstGeom prst="rect">
+            <a:avLst/>
+          </a:prstGeom>
+          <a:noFill/>
+        </p:spPr>
+        <p:txBody>
+          <a:bodyPr wrap="none" rtlCol="0">
+            <a:spAutoFit/>
+          </a:bodyPr>
+          <a:lstStyle/>
+          <a:p>
+            <a:pPr algn="ctr"/>
+            <a:r>
+              <a:rPr lang="en-US" sz="700" dirty="0" err="1"/>
+              <a:t>if_id_instr</a:t>
+            </a:r>
+            <a:r>
+              <a:rPr lang="en-US" sz="700" dirty="0"/>
+              <a:t>(11 </a:t>
+            </a:r>
+            <a:r>
+              <a:rPr lang="en-US" sz="700" dirty="0" err="1"/>
+              <a:t>downto</a:t>
+            </a:r>
+            <a:r>
+              <a:rPr lang="en-US" sz="700" dirty="0"/>
+              <a:t> 7)</a:t>
+            </a:r>
+          </a:p>
+        </p:txBody>
+      </p:sp>
+      <p:sp>
+        <p:nvSpPr>
+          <p:cNvPr id="119" name="TextBox 118">
+            <a:extLst>
+              <a:ext uri="{FF2B5EF4-FFF2-40B4-BE49-F238E27FC236}">
+                <a16:creationId xmlns:a16="http://schemas.microsoft.com/office/drawing/2014/main" id="{82C621C4-41AF-EB37-FDDB-CC4715F69213}"/>
+              </a:ext>
+            </a:extLst>
+          </p:cNvPr>
+          <p:cNvSpPr txBox="1"/>
+          <p:nvPr/>
+        </p:nvSpPr>
+        <p:spPr>
+          <a:xfrm rot="16200000">
+            <a:off x="1075307" y="4595823"/>
+            <a:ext cx="1034257" cy="200055"/>
+          </a:xfrm>
+          <a:prstGeom prst="rect">
+            <a:avLst/>
+          </a:prstGeom>
+          <a:noFill/>
+        </p:spPr>
+        <p:txBody>
+          <a:bodyPr wrap="none" rtlCol="0">
+            <a:spAutoFit/>
+          </a:bodyPr>
+          <a:lstStyle/>
+          <a:p>
+            <a:pPr algn="ctr"/>
+            <a:r>
+              <a:rPr lang="en-US" sz="700" dirty="0" err="1"/>
+              <a:t>if_id_instr</a:t>
+            </a:r>
+            <a:r>
+              <a:rPr lang="en-US" sz="700" dirty="0"/>
+              <a:t>(6 </a:t>
+            </a:r>
+            <a:r>
+              <a:rPr lang="en-US" sz="700" dirty="0" err="1"/>
+              <a:t>downto</a:t>
+            </a:r>
+            <a:r>
+              <a:rPr lang="en-US" sz="700" dirty="0"/>
+              <a:t> 0)</a:t>
+            </a:r>
+          </a:p>
+        </p:txBody>
+      </p:sp>
+      <p:sp>
+        <p:nvSpPr>
+          <p:cNvPr id="120" name="TextBox 119">
+            <a:extLst>
+              <a:ext uri="{FF2B5EF4-FFF2-40B4-BE49-F238E27FC236}">
+                <a16:creationId xmlns:a16="http://schemas.microsoft.com/office/drawing/2014/main" id="{147F78E8-2DC9-1F5E-67F0-6A53FEF93891}"/>
+              </a:ext>
+            </a:extLst>
+          </p:cNvPr>
+          <p:cNvSpPr txBox="1"/>
+          <p:nvPr/>
+        </p:nvSpPr>
+        <p:spPr>
+          <a:xfrm>
+            <a:off x="6055360" y="3400264"/>
+            <a:ext cx="521297" cy="230832"/>
+          </a:xfrm>
+          <a:prstGeom prst="rect">
+            <a:avLst/>
+          </a:prstGeom>
+          <a:noFill/>
+        </p:spPr>
+        <p:txBody>
+          <a:bodyPr wrap="none" rtlCol="0">
+            <a:spAutoFit/>
+          </a:bodyPr>
+          <a:lstStyle/>
+          <a:p>
+            <a:pPr algn="ctr"/>
+            <a:r>
+              <a:rPr lang="en-US" sz="900" dirty="0" err="1"/>
+              <a:t>alu_op</a:t>
+            </a:r>
+            <a:endParaRPr lang="en-US" sz="900" dirty="0"/>
+          </a:p>
+        </p:txBody>
+      </p:sp>
+      <p:sp>
+        <p:nvSpPr>
+          <p:cNvPr id="121" name="TextBox 120">
+            <a:extLst>
+              <a:ext uri="{FF2B5EF4-FFF2-40B4-BE49-F238E27FC236}">
+                <a16:creationId xmlns:a16="http://schemas.microsoft.com/office/drawing/2014/main" id="{A759E5F0-0C95-A820-049E-0C36CE8EEB95}"/>
+              </a:ext>
+            </a:extLst>
+          </p:cNvPr>
+          <p:cNvSpPr txBox="1"/>
+          <p:nvPr/>
+        </p:nvSpPr>
+        <p:spPr>
+          <a:xfrm>
+            <a:off x="5530564" y="3429000"/>
+            <a:ext cx="548548" cy="230832"/>
+          </a:xfrm>
+          <a:prstGeom prst="rect">
+            <a:avLst/>
+          </a:prstGeom>
+          <a:noFill/>
+        </p:spPr>
+        <p:txBody>
+          <a:bodyPr wrap="none" rtlCol="0">
+            <a:spAutoFit/>
+          </a:bodyPr>
+          <a:lstStyle/>
+          <a:p>
+            <a:pPr algn="ctr"/>
+            <a:r>
+              <a:rPr lang="en-US" sz="900" dirty="0" err="1"/>
+              <a:t>alu_src</a:t>
+            </a:r>
+            <a:endParaRPr lang="en-US" sz="900" dirty="0"/>
+          </a:p>
+        </p:txBody>
+      </p:sp>
+      <p:sp>
+        <p:nvSpPr>
+          <p:cNvPr id="122" name="TextBox 121">
+            <a:extLst>
+              <a:ext uri="{FF2B5EF4-FFF2-40B4-BE49-F238E27FC236}">
+                <a16:creationId xmlns:a16="http://schemas.microsoft.com/office/drawing/2014/main" id="{7275FD5D-02F0-AEAF-D9FA-962888062F96}"/>
+              </a:ext>
+            </a:extLst>
+          </p:cNvPr>
+          <p:cNvSpPr txBox="1"/>
+          <p:nvPr/>
+        </p:nvSpPr>
+        <p:spPr>
+          <a:xfrm>
+            <a:off x="8687894" y="3384831"/>
+            <a:ext cx="679994" cy="230832"/>
+          </a:xfrm>
+          <a:prstGeom prst="rect">
+            <a:avLst/>
+          </a:prstGeom>
+          <a:noFill/>
+        </p:spPr>
+        <p:txBody>
+          <a:bodyPr wrap="none" rtlCol="0">
+            <a:spAutoFit/>
+          </a:bodyPr>
+          <a:lstStyle/>
+          <a:p>
+            <a:r>
+              <a:rPr lang="en-US" sz="900" dirty="0" err="1"/>
+              <a:t>alu_result</a:t>
+            </a:r>
+            <a:endParaRPr lang="en-US" sz="900" dirty="0"/>
+          </a:p>
+        </p:txBody>
+      </p:sp>
+      <p:sp>
+        <p:nvSpPr>
+          <p:cNvPr id="123" name="TextBox 122">
+            <a:extLst>
+              <a:ext uri="{FF2B5EF4-FFF2-40B4-BE49-F238E27FC236}">
+                <a16:creationId xmlns:a16="http://schemas.microsoft.com/office/drawing/2014/main" id="{E9F1DE03-B5E4-9ADD-19B2-43795E457CBD}"/>
+              </a:ext>
+            </a:extLst>
+          </p:cNvPr>
+          <p:cNvSpPr txBox="1"/>
+          <p:nvPr/>
+        </p:nvSpPr>
+        <p:spPr>
+          <a:xfrm>
+            <a:off x="9275995" y="3617792"/>
+            <a:ext cx="674972" cy="507831"/>
+          </a:xfrm>
+          <a:prstGeom prst="rect">
+            <a:avLst/>
+          </a:prstGeom>
+          <a:noFill/>
+        </p:spPr>
+        <p:txBody>
+          <a:bodyPr wrap="square" rtlCol="0">
+            <a:spAutoFit/>
+          </a:bodyPr>
+          <a:lstStyle/>
+          <a:p>
+            <a:pPr algn="ctr"/>
+            <a:r>
+              <a:rPr lang="en-US" sz="900" dirty="0"/>
+              <a:t>branch, jump, state</a:t>
+            </a:r>
+          </a:p>
+        </p:txBody>
+      </p:sp>
+      <p:sp>
+        <p:nvSpPr>
+          <p:cNvPr id="125" name="TextBox 124">
+            <a:extLst>
+              <a:ext uri="{FF2B5EF4-FFF2-40B4-BE49-F238E27FC236}">
+                <a16:creationId xmlns:a16="http://schemas.microsoft.com/office/drawing/2014/main" id="{C2472169-6862-3636-DB88-865A4D08F4EA}"/>
+              </a:ext>
+            </a:extLst>
+          </p:cNvPr>
+          <p:cNvSpPr txBox="1"/>
+          <p:nvPr/>
+        </p:nvSpPr>
+        <p:spPr>
+          <a:xfrm>
+            <a:off x="4635120" y="5744237"/>
+            <a:ext cx="575799" cy="230832"/>
+          </a:xfrm>
+          <a:prstGeom prst="rect">
+            <a:avLst/>
+          </a:prstGeom>
+          <a:noFill/>
+        </p:spPr>
+        <p:txBody>
+          <a:bodyPr wrap="none" rtlCol="0">
+            <a:spAutoFit/>
+          </a:bodyPr>
+          <a:lstStyle/>
+          <a:p>
+            <a:pPr algn="ctr"/>
+            <a:r>
+              <a:rPr lang="en-US" sz="900" dirty="0" err="1"/>
+              <a:t>next_pc</a:t>
+            </a:r>
+            <a:endParaRPr lang="en-US" sz="900" dirty="0"/>
           </a:p>
         </p:txBody>
       </p:sp>

</xml_diff>